<commit_message>
Add blind test stage: sealed last fold, selection made without it
- blindtest.py re-selects the model per cluster using only backtest folds
  whose targets end before the sealed fold, then scores all four models on
  the sealed 8 weeks and reports per-cluster regret; refits nothing
- report, deck, eval gates (42 now), README, CLAUDE.md and tests updated
</commit_message>
<xml_diff>
--- a/reports/deck.pptx
+++ b/reports/deck.pptx
@@ -5568,6 +5568,21 @@
             </a:pPr>
             <a:r>
               <a:t>•  Selection rule: lowest mean WAPE over 8 folds unless a simpler or steadier model is within 0.02. LightGBM wins outright in all six clusters.</a:t>
+            </a:r>
+          </a:p>
+          <a:p>
+            <a:pPr>
+              <a:spcAft>
+                <a:spcPts val="600"/>
+              </a:spcAft>
+              <a:defRPr sz="1100">
+                <a:solidFill>
+                  <a:srgbClr val="18221D"/>
+                </a:solidFill>
+              </a:defRPr>
+            </a:pPr>
+            <a:r>
+              <a:t>•  Blind test: with the last 8 weeks sealed and the choice made without them, LightGBM still leads (WAPE 0.115 vs ETS 0.123); the pre-registered choice held in 4 of 6 clusters.</a:t>
             </a:r>
           </a:p>
           <a:p>

</xml_diff>

<commit_message>
Add per-series risk timeline figure and the DC-vs-store allocation finding
</commit_message>
<xml_diff>
--- a/reports/deck.pptx
+++ b/reports/deck.pptx
@@ -6539,6 +6539,30 @@
           </a:prstGeom>
         </p:spPr>
       </p:pic>
+      <p:pic>
+        <p:nvPicPr>
+          <p:cNvPr id="9" name="Picture 8" descr="risk_timeline.png"/>
+          <p:cNvPicPr>
+            <a:picLocks noChangeAspect="1"/>
+          </p:cNvPicPr>
+          <p:nvPr/>
+        </p:nvPicPr>
+        <p:blipFill>
+          <a:blip r:embed="rId3"/>
+          <a:stretch>
+            <a:fillRect/>
+          </a:stretch>
+        </p:blipFill>
+        <p:spPr>
+          <a:xfrm>
+            <a:off x="6400800" y="3566160"/>
+            <a:ext cx="2830245" cy="2834640"/>
+          </a:xfrm>
+          <a:prstGeom prst="rect">
+            <a:avLst/>
+          </a:prstGeom>
+        </p:spPr>
+      </p:pic>
     </p:spTree>
   </p:cSld>
   <p:clrMapOvr>

</xml_diff>